<commit_message>
Updated the Smith Predictor
</commit_message>
<xml_diff>
--- a/Activities/Presentations/Smith Predictor.pptx
+++ b/Activities/Presentations/Smith Predictor.pptx
@@ -275,7 +275,7 @@
           <a:p>
             <a:fld id="{6936065D-AC5C-417B-9565-B1B64C082BD3}" type="datetimeFigureOut">
               <a:rPr lang="en-US" smtClean="0"/>
-              <a:t>6/28/2020</a:t>
+              <a:t>8/2/2020</a:t>
             </a:fld>
             <a:endParaRPr lang="en-US"/>
           </a:p>
@@ -473,7 +473,7 @@
           <a:p>
             <a:fld id="{6936065D-AC5C-417B-9565-B1B64C082BD3}" type="datetimeFigureOut">
               <a:rPr lang="en-US" smtClean="0"/>
-              <a:t>6/28/2020</a:t>
+              <a:t>8/2/2020</a:t>
             </a:fld>
             <a:endParaRPr lang="en-US"/>
           </a:p>
@@ -681,7 +681,7 @@
           <a:p>
             <a:fld id="{6936065D-AC5C-417B-9565-B1B64C082BD3}" type="datetimeFigureOut">
               <a:rPr lang="en-US" smtClean="0"/>
-              <a:t>6/28/2020</a:t>
+              <a:t>8/2/2020</a:t>
             </a:fld>
             <a:endParaRPr lang="en-US"/>
           </a:p>
@@ -879,7 +879,7 @@
           <a:p>
             <a:fld id="{6936065D-AC5C-417B-9565-B1B64C082BD3}" type="datetimeFigureOut">
               <a:rPr lang="en-US" smtClean="0"/>
-              <a:t>6/28/2020</a:t>
+              <a:t>8/2/2020</a:t>
             </a:fld>
             <a:endParaRPr lang="en-US"/>
           </a:p>
@@ -1154,7 +1154,7 @@
           <a:p>
             <a:fld id="{6936065D-AC5C-417B-9565-B1B64C082BD3}" type="datetimeFigureOut">
               <a:rPr lang="en-US" smtClean="0"/>
-              <a:t>6/28/2020</a:t>
+              <a:t>8/2/2020</a:t>
             </a:fld>
             <a:endParaRPr lang="en-US"/>
           </a:p>
@@ -1419,7 +1419,7 @@
           <a:p>
             <a:fld id="{6936065D-AC5C-417B-9565-B1B64C082BD3}" type="datetimeFigureOut">
               <a:rPr lang="en-US" smtClean="0"/>
-              <a:t>6/28/2020</a:t>
+              <a:t>8/2/2020</a:t>
             </a:fld>
             <a:endParaRPr lang="en-US"/>
           </a:p>
@@ -1831,7 +1831,7 @@
           <a:p>
             <a:fld id="{6936065D-AC5C-417B-9565-B1B64C082BD3}" type="datetimeFigureOut">
               <a:rPr lang="en-US" smtClean="0"/>
-              <a:t>6/28/2020</a:t>
+              <a:t>8/2/2020</a:t>
             </a:fld>
             <a:endParaRPr lang="en-US"/>
           </a:p>
@@ -1972,7 +1972,7 @@
           <a:p>
             <a:fld id="{6936065D-AC5C-417B-9565-B1B64C082BD3}" type="datetimeFigureOut">
               <a:rPr lang="en-US" smtClean="0"/>
-              <a:t>6/28/2020</a:t>
+              <a:t>8/2/2020</a:t>
             </a:fld>
             <a:endParaRPr lang="en-US"/>
           </a:p>
@@ -2085,7 +2085,7 @@
           <a:p>
             <a:fld id="{6936065D-AC5C-417B-9565-B1B64C082BD3}" type="datetimeFigureOut">
               <a:rPr lang="en-US" smtClean="0"/>
-              <a:t>6/28/2020</a:t>
+              <a:t>8/2/2020</a:t>
             </a:fld>
             <a:endParaRPr lang="en-US"/>
           </a:p>
@@ -2396,7 +2396,7 @@
           <a:p>
             <a:fld id="{6936065D-AC5C-417B-9565-B1B64C082BD3}" type="datetimeFigureOut">
               <a:rPr lang="en-US" smtClean="0"/>
-              <a:t>6/28/2020</a:t>
+              <a:t>8/2/2020</a:t>
             </a:fld>
             <a:endParaRPr lang="en-US"/>
           </a:p>
@@ -2684,7 +2684,7 @@
           <a:p>
             <a:fld id="{6936065D-AC5C-417B-9565-B1B64C082BD3}" type="datetimeFigureOut">
               <a:rPr lang="en-US" smtClean="0"/>
-              <a:t>6/28/2020</a:t>
+              <a:t>8/2/2020</a:t>
             </a:fld>
             <a:endParaRPr lang="en-US"/>
           </a:p>
@@ -2925,7 +2925,7 @@
           <a:p>
             <a:fld id="{6936065D-AC5C-417B-9565-B1B64C082BD3}" type="datetimeFigureOut">
               <a:rPr lang="en-US" smtClean="0"/>
-              <a:t>6/28/2020</a:t>
+              <a:t>8/2/2020</a:t>
             </a:fld>
             <a:endParaRPr lang="en-US"/>
           </a:p>
@@ -3392,7 +3392,31 @@
           <a:bodyPr/>
           <a:lstStyle/>
           <a:p>
+            <a:r>
+              <a:rPr lang="en-US" dirty="0"/>
+              <a:t>ME</a:t>
+            </a:r>
+          </a:p>
+          <a:p>
+            <a:r>
+              <a:rPr lang="en-US" dirty="0" err="1"/>
+              <a:t>Universitas</a:t>
+            </a:r>
+            <a:r>
+              <a:rPr lang="en-US" dirty="0"/>
+              <a:t> </a:t>
+            </a:r>
+            <a:r>
+              <a:rPr lang="en-US" dirty="0" err="1"/>
+              <a:t>Pertamina</a:t>
+            </a:r>
             <a:endParaRPr lang="en-US" dirty="0"/>
+          </a:p>
+          <a:p>
+            <a:r>
+              <a:rPr lang="en-US" dirty="0"/>
+              <a:t>2020</a:t>
+            </a:r>
           </a:p>
         </p:txBody>
       </p:sp>
@@ -3549,8 +3573,8 @@
           </a:p>
         </p:txBody>
       </p:sp>
-      <mc:AlternateContent xmlns:mc="http://schemas.openxmlformats.org/markup-compatibility/2006">
-        <mc:Choice xmlns:a14="http://schemas.microsoft.com/office/drawing/2010/main" Requires="a14">
+      <mc:AlternateContent xmlns:mc="http://schemas.openxmlformats.org/markup-compatibility/2006" xmlns:a14="http://schemas.microsoft.com/office/drawing/2010/main">
+        <mc:Choice Requires="a14">
           <p:sp>
             <p:nvSpPr>
               <p:cNvPr id="3" name="Content Placeholder 2">
@@ -3614,7 +3638,7 @@
             </p:txBody>
           </p:sp>
         </mc:Choice>
-        <mc:Fallback>
+        <mc:Fallback xmlns="">
           <p:sp>
             <p:nvSpPr>
               <p:cNvPr id="3" name="Content Placeholder 2">
@@ -3977,6 +4001,154 @@
           </a:prstGeom>
         </p:spPr>
       </p:pic>
+      <p:cxnSp>
+        <p:nvCxnSpPr>
+          <p:cNvPr id="5" name="Straight Arrow Connector 4">
+            <a:extLst>
+              <a:ext uri="{FF2B5EF4-FFF2-40B4-BE49-F238E27FC236}">
+                <a16:creationId xmlns:a16="http://schemas.microsoft.com/office/drawing/2014/main" id="{00F6275A-31AA-465E-8B21-2191E6697B78}"/>
+              </a:ext>
+            </a:extLst>
+          </p:cNvPr>
+          <p:cNvCxnSpPr/>
+          <p:nvPr/>
+        </p:nvCxnSpPr>
+        <p:spPr>
+          <a:xfrm flipH="1">
+            <a:off x="4899546" y="1992573"/>
+            <a:ext cx="777923" cy="600502"/>
+          </a:xfrm>
+          <a:prstGeom prst="straightConnector1">
+            <a:avLst/>
+          </a:prstGeom>
+          <a:ln w="38100">
+            <a:tailEnd type="triangle"/>
+          </a:ln>
+        </p:spPr>
+        <p:style>
+          <a:lnRef idx="1">
+            <a:schemeClr val="accent2"/>
+          </a:lnRef>
+          <a:fillRef idx="0">
+            <a:schemeClr val="accent2"/>
+          </a:fillRef>
+          <a:effectRef idx="0">
+            <a:schemeClr val="accent2"/>
+          </a:effectRef>
+          <a:fontRef idx="minor">
+            <a:schemeClr val="tx1"/>
+          </a:fontRef>
+        </p:style>
+      </p:cxnSp>
+      <p:cxnSp>
+        <p:nvCxnSpPr>
+          <p:cNvPr id="6" name="Straight Arrow Connector 5">
+            <a:extLst>
+              <a:ext uri="{FF2B5EF4-FFF2-40B4-BE49-F238E27FC236}">
+                <a16:creationId xmlns:a16="http://schemas.microsoft.com/office/drawing/2014/main" id="{21250AC4-0F57-4144-A66D-B080C51DC9E6}"/>
+              </a:ext>
+            </a:extLst>
+          </p:cNvPr>
+          <p:cNvCxnSpPr/>
+          <p:nvPr/>
+        </p:nvCxnSpPr>
+        <p:spPr>
+          <a:xfrm flipH="1">
+            <a:off x="6905766" y="2254665"/>
+            <a:ext cx="777923" cy="600502"/>
+          </a:xfrm>
+          <a:prstGeom prst="straightConnector1">
+            <a:avLst/>
+          </a:prstGeom>
+          <a:ln w="38100">
+            <a:tailEnd type="triangle"/>
+          </a:ln>
+        </p:spPr>
+        <p:style>
+          <a:lnRef idx="1">
+            <a:schemeClr val="accent2"/>
+          </a:lnRef>
+          <a:fillRef idx="0">
+            <a:schemeClr val="accent2"/>
+          </a:fillRef>
+          <a:effectRef idx="0">
+            <a:schemeClr val="accent2"/>
+          </a:effectRef>
+          <a:fontRef idx="minor">
+            <a:schemeClr val="tx1"/>
+          </a:fontRef>
+        </p:style>
+      </p:cxnSp>
+      <p:sp>
+        <p:nvSpPr>
+          <p:cNvPr id="7" name="TextBox 6">
+            <a:extLst>
+              <a:ext uri="{FF2B5EF4-FFF2-40B4-BE49-F238E27FC236}">
+                <a16:creationId xmlns:a16="http://schemas.microsoft.com/office/drawing/2014/main" id="{26250AF3-1679-45DA-A06A-F7DC82E9094F}"/>
+              </a:ext>
+            </a:extLst>
+          </p:cNvPr>
+          <p:cNvSpPr txBox="1"/>
+          <p:nvPr/>
+        </p:nvSpPr>
+        <p:spPr>
+          <a:xfrm>
+            <a:off x="5288507" y="1705969"/>
+            <a:ext cx="1576842" cy="369332"/>
+          </a:xfrm>
+          <a:prstGeom prst="rect">
+            <a:avLst/>
+          </a:prstGeom>
+          <a:noFill/>
+        </p:spPr>
+        <p:txBody>
+          <a:bodyPr wrap="none" rtlCol="0">
+            <a:spAutoFit/>
+          </a:bodyPr>
+          <a:lstStyle/>
+          <a:p>
+            <a:r>
+              <a:rPr lang="en-US" dirty="0"/>
+              <a:t>Less overshoot</a:t>
+            </a:r>
+          </a:p>
+        </p:txBody>
+      </p:sp>
+      <p:sp>
+        <p:nvSpPr>
+          <p:cNvPr id="9" name="TextBox 8">
+            <a:extLst>
+              <a:ext uri="{FF2B5EF4-FFF2-40B4-BE49-F238E27FC236}">
+                <a16:creationId xmlns:a16="http://schemas.microsoft.com/office/drawing/2014/main" id="{E76C666F-F35E-4978-BC83-6A646D9DD4D5}"/>
+              </a:ext>
+            </a:extLst>
+          </p:cNvPr>
+          <p:cNvSpPr txBox="1"/>
+          <p:nvPr/>
+        </p:nvSpPr>
+        <p:spPr>
+          <a:xfrm>
+            <a:off x="7080039" y="1945227"/>
+            <a:ext cx="1667892" cy="369332"/>
+          </a:xfrm>
+          <a:prstGeom prst="rect">
+            <a:avLst/>
+          </a:prstGeom>
+          <a:noFill/>
+        </p:spPr>
+        <p:txBody>
+          <a:bodyPr wrap="none" rtlCol="0">
+            <a:spAutoFit/>
+          </a:bodyPr>
+          <a:lstStyle/>
+          <a:p>
+            <a:r>
+              <a:rPr lang="en-US" dirty="0"/>
+              <a:t>Less oscillations</a:t>
+            </a:r>
+          </a:p>
+        </p:txBody>
+      </p:sp>
     </p:spTree>
     <p:extLst>
       <p:ext uri="{BB962C8B-B14F-4D97-AF65-F5344CB8AC3E}">
@@ -4066,15 +4238,7 @@
             </a:r>
             <a:r>
               <a:rPr lang="en-US" dirty="0"/>
-              <a:t>O. J. . Smith, “Closed Control of Loop with Dead Time,” </a:t>
-            </a:r>
-            <a:r>
-              <a:rPr lang="en-US" i="1" dirty="0"/>
-              <a:t>Chem. Eng. Prog.</a:t>
-            </a:r>
-            <a:r>
-              <a:rPr lang="en-US" dirty="0"/>
-              <a:t>, vol. 53, pp. 217–219, 1957, [Online]. Available: https://ci.nii.ac.jp/naid/10026070106/en/.</a:t>
+              <a:t>O. J. M. Smith, “Closed Control of Loop with Dead Time,” Chemical Engineering Progress 53(5), pp 217-219, 1957</a:t>
             </a:r>
           </a:p>
         </p:txBody>

</xml_diff>